<commit_message>
Tighten both decks; fix text floating to the middle of every card
Rendered through LibreOffice and looked at each slide, which caught a bug no
structural check would: python-pptx autoshapes anchor text vertically CENTRED,
so every card's heading floated into its middle and left the top looking empty.
rect() now anchors TOP; the two callers that want centring set it back.

Sized every box to its content rather than to the slide. First pass
over-corrected - cards grew to fill the height and the text then sat in a tall
empty box - so this pass shrinks them and fills the remaining foot of slides
3, 5 and 6 with a navy takeaway strip carrying the one line to remember.

The monospace derivation block on slide 5 wrapped mid-token ("40.1 Ω" and
"V_oc²/4R_int" both broke across lines). Split into four shorter lines that fit
the column.

Trimmed roughly a third of the words throughout.

Co-Authored-By: Claude Opus 5 (1M context) <noreply@anthropic.com>
</commit_message>
<xml_diff>
--- a/docs/slides/jeong_setup_and_results.pptx
+++ b/docs/slides/jeong_setup_and_results.pptx
@@ -3971,7 +3971,7 @@
           </a:fontRef>
         </p:style>
         <p:txBody>
-          <a:bodyPr rtlCol="0" anchor="ctr" wrap="square"/>
+          <a:bodyPr rtlCol="0" anchor="t" wrap="square"/>
           <a:lstStyle/>
           <a:p>
             <a:pPr algn="ctr"/>
@@ -4015,7 +4015,7 @@
           </a:fontRef>
         </p:style>
         <p:txBody>
-          <a:bodyPr rtlCol="0" anchor="ctr" wrap="square"/>
+          <a:bodyPr rtlCol="0" anchor="t" wrap="square"/>
           <a:lstStyle/>
           <a:p>
             <a:pPr algn="ctr"/>
@@ -4192,7 +4192,7 @@
           </a:fontRef>
         </p:style>
         <p:txBody>
-          <a:bodyPr rtlCol="0" anchor="ctr" wrap="square"/>
+          <a:bodyPr rtlCol="0" anchor="t" wrap="square"/>
           <a:lstStyle/>
           <a:p>
             <a:pPr algn="ctr"/>
@@ -4309,7 +4309,7 @@
           </a:fontRef>
         </p:style>
         <p:txBody>
-          <a:bodyPr rtlCol="0" anchor="ctr" wrap="square"/>
+          <a:bodyPr rtlCol="0" anchor="t" wrap="square"/>
           <a:lstStyle/>
           <a:p>
             <a:pPr algn="ctr"/>
@@ -4353,7 +4353,7 @@
           </a:fontRef>
         </p:style>
         <p:txBody>
-          <a:bodyPr rtlCol="0" anchor="ctr" wrap="square"/>
+          <a:bodyPr rtlCol="0" anchor="t" wrap="square"/>
           <a:lstStyle/>
           <a:p>
             <a:pPr algn="ctr"/>
@@ -4475,7 +4475,7 @@
           </a:fontRef>
         </p:style>
         <p:txBody>
-          <a:bodyPr rtlCol="0" anchor="ctr" wrap="square"/>
+          <a:bodyPr rtlCol="0" anchor="t" wrap="square"/>
           <a:lstStyle/>
           <a:p>
             <a:pPr algn="ctr"/>
@@ -4491,7 +4491,7 @@
         <p:spPr>
           <a:xfrm>
             <a:off x="502920" y="1591056"/>
-            <a:ext cx="6675120" cy="3566160"/>
+            <a:ext cx="6675120" cy="4480560"/>
           </a:xfrm>
           <a:prstGeom prst="rect">
             <a:avLst/>
@@ -4582,7 +4582,7 @@
         <p:spPr>
           <a:xfrm>
             <a:off x="7498079" y="1591056"/>
-            <a:ext cx="4206240" cy="4206240"/>
+            <a:ext cx="4206240" cy="4480560"/>
           </a:xfrm>
           <a:prstGeom prst="rect">
             <a:avLst/>
@@ -4657,7 +4657,7 @@
                 </a:solidFill>
                 <a:latin typeface="Calibri"/>
               </a:rPr>
-              <a:t>Python host → USB → Portenta Machine Control → RS-485 Modbus RTU → drive</a:t>
+              <a:t>Python → USB → Portenta Machine Control → RS-485 Modbus → drive</a:t>
             </a:r>
           </a:p>
           <a:p>
@@ -4682,7 +4682,7 @@
                 </a:solidFill>
                 <a:latin typeface="Calibri"/>
               </a:rPr>
-              <a:t>Chroma 63004-150-60. Sets the rotor's operating point and is the best V/I instrument on the rig</a:t>
+              <a:t>Chroma 63004-150-60 — sets the rotor's operating point and measures it</a:t>
             </a:r>
           </a:p>
           <a:p>
@@ -4789,7 +4789,7 @@
                 </a:solidFill>
                 <a:latin typeface="Calibri"/>
               </a:rPr>
-              <a:t>Blade section: </a:t>
+              <a:t>Blade: </a:t>
             </a:r>
             <a:r>
               <a:rPr sz="1300" b="0">
@@ -4798,7 +4798,7 @@
                 </a:solidFill>
                 <a:latin typeface="Calibri"/>
               </a:rPr>
-              <a:t>thin cambered plate, 1.79 mm wall, t/c 4%, 42% camber, 183° turning, square edges.</a:t>
+              <a:t>thin cambered plate — 1.79 mm wall, t/c 4%, 42% camber, 183° turning. Not an airfoil.</a:t>
             </a:r>
           </a:p>
         </p:txBody>
@@ -4858,7 +4858,7 @@
           </a:fontRef>
         </p:style>
         <p:txBody>
-          <a:bodyPr rtlCol="0" anchor="ctr" wrap="square"/>
+          <a:bodyPr rtlCol="0" anchor="t" wrap="square"/>
           <a:lstStyle/>
           <a:p>
             <a:pPr algn="ctr"/>
@@ -4902,7 +4902,7 @@
           </a:fontRef>
         </p:style>
         <p:txBody>
-          <a:bodyPr rtlCol="0" anchor="ctr" wrap="square"/>
+          <a:bodyPr rtlCol="0" anchor="t" wrap="square"/>
           <a:lstStyle/>
           <a:p>
             <a:pPr algn="ctr"/>
@@ -5024,7 +5024,7 @@
           </a:fontRef>
         </p:style>
         <p:txBody>
-          <a:bodyPr rtlCol="0" anchor="ctr" wrap="square"/>
+          <a:bodyPr rtlCol="0" anchor="t" wrap="square"/>
           <a:lstStyle/>
           <a:p>
             <a:pPr algn="ctr"/>
@@ -5115,7 +5115,7 @@
         <p:spPr>
           <a:xfrm>
             <a:off x="502920" y="2688336"/>
-            <a:ext cx="3538728" cy="3246120"/>
+            <a:ext cx="3538728" cy="2697480"/>
           </a:xfrm>
           <a:prstGeom prst="rect">
             <a:avLst/>
@@ -5145,7 +5145,7 @@
           </a:fontRef>
         </p:style>
         <p:txBody>
-          <a:bodyPr rtlCol="0" anchor="ctr" wrap="square" lIns="182880" rIns="182880" tIns="164592"/>
+          <a:bodyPr rtlCol="0" anchor="t" wrap="square" lIns="182880" rIns="182880" tIns="164592"/>
           <a:lstStyle/>
           <a:p>
             <a:pPr algn="l">
@@ -5276,7 +5276,7 @@
         <p:spPr>
           <a:xfrm>
             <a:off x="4270248" y="2688336"/>
-            <a:ext cx="3538728" cy="3246120"/>
+            <a:ext cx="3538728" cy="2697480"/>
           </a:xfrm>
           <a:prstGeom prst="rect">
             <a:avLst/>
@@ -5306,7 +5306,7 @@
           </a:fontRef>
         </p:style>
         <p:txBody>
-          <a:bodyPr rtlCol="0" anchor="ctr" wrap="square" lIns="182880" rIns="182880" tIns="164592"/>
+          <a:bodyPr rtlCol="0" anchor="t" wrap="square" lIns="182880" rIns="182880" tIns="164592"/>
           <a:lstStyle/>
           <a:p>
             <a:pPr algn="l">
@@ -5389,7 +5389,7 @@
                 </a:solidFill>
                 <a:latin typeface="Calibri"/>
               </a:rPr>
-              <a:t>A direct host-to-drive cable must never be landed at the same time</a:t>
+              <a:t>A direct host-to-drive cable must never be landed as well</a:t>
             </a:r>
           </a:p>
           <a:p>
@@ -5423,7 +5423,7 @@
                 </a:solidFill>
                 <a:latin typeface="Calibri"/>
               </a:rPr>
-              <a:t>Two devices commanding a 15 HP fan, neither aware of the other, is the failure this design exists to prevent</a:t>
+              <a:t>Two devices commanding a 15 HP fan, neither aware of the other, is the failure this prevents</a:t>
             </a:r>
           </a:p>
         </p:txBody>
@@ -5437,7 +5437,7 @@
         <p:spPr>
           <a:xfrm>
             <a:off x="8037576" y="2688336"/>
-            <a:ext cx="3538728" cy="3246120"/>
+            <a:ext cx="3538728" cy="2697480"/>
           </a:xfrm>
           <a:prstGeom prst="rect">
             <a:avLst/>
@@ -5467,7 +5467,7 @@
           </a:fontRef>
         </p:style>
         <p:txBody>
-          <a:bodyPr rtlCol="0" anchor="ctr" wrap="square" lIns="182880" rIns="182880" tIns="164592"/>
+          <a:bodyPr rtlCol="0" anchor="t" wrap="square" lIns="182880" rIns="182880" tIns="164592"/>
           <a:lstStyle/>
           <a:p>
             <a:pPr algn="l">
@@ -5557,6 +5557,40 @@
                 </a:solidFill>
                 <a:latin typeface="Calibri"/>
               </a:rPr>
+              <a:t/>
+            </a:r>
+            <a:r>
+              <a:rPr sz="1250" b="0">
+                <a:solidFill>
+                  <a:srgbClr val="0D2338"/>
+                </a:solidFill>
+                <a:latin typeface="Calibri"/>
+              </a:rPr>
+              <a:t>Enforced on every path that can move the fan</a:t>
+            </a:r>
+          </a:p>
+          <a:p>
+            <a:pPr algn="l">
+              <a:spcAft>
+                <a:spcPts val="900"/>
+              </a:spcAft>
+            </a:pPr>
+            <a:r>
+              <a:rPr sz="1250" b="0">
+                <a:solidFill>
+                  <a:srgbClr val="2277B3"/>
+                </a:solidFill>
+                <a:latin typeface="Calibri"/>
+              </a:rPr>
+              <a:t>• </a:t>
+            </a:r>
+            <a:r>
+              <a:rPr sz="1250" b="1">
+                <a:solidFill>
+                  <a:srgbClr val="002147"/>
+                </a:solidFill>
+                <a:latin typeface="Calibri"/>
+              </a:rPr>
               <a:t>If the fan cannot be confirmed stopped,</a:t>
             </a:r>
             <a:r>
@@ -5567,6 +5601,63 @@
                 <a:latin typeface="Calibri"/>
               </a:rPr>
               <a:t> the load stays on</a:t>
+            </a:r>
+          </a:p>
+        </p:txBody>
+      </p:sp>
+      <p:sp>
+        <p:nvSpPr>
+          <p:cNvPr id="11" name="Rectangle 10"/>
+          <p:cNvSpPr/>
+          <p:nvPr/>
+        </p:nvSpPr>
+        <p:spPr>
+          <a:xfrm>
+            <a:off x="502920" y="5742432"/>
+            <a:ext cx="11185855" cy="658368"/>
+          </a:xfrm>
+          <a:prstGeom prst="rect">
+            <a:avLst/>
+          </a:prstGeom>
+          <a:solidFill>
+            <a:srgbClr val="002147"/>
+          </a:solidFill>
+          <a:ln>
+            <a:noFill/>
+          </a:ln>
+          <a:effectLst/>
+        </p:spPr>
+        <p:style>
+          <a:lnRef idx="1">
+            <a:schemeClr val="accent1"/>
+          </a:lnRef>
+          <a:fillRef idx="3">
+            <a:schemeClr val="accent1"/>
+          </a:fillRef>
+          <a:effectRef idx="2">
+            <a:schemeClr val="accent1"/>
+          </a:effectRef>
+          <a:fontRef idx="minor">
+            <a:schemeClr val="lt1"/>
+          </a:fontRef>
+        </p:style>
+        <p:txBody>
+          <a:bodyPr rtlCol="0" anchor="ctr" wrap="square" lIns="256032"/>
+          <a:lstStyle/>
+          <a:p>
+            <a:pPr algn="l">
+              <a:spcAft>
+                <a:spcPts val="0"/>
+              </a:spcAft>
+            </a:pPr>
+            <a:r>
+              <a:rPr sz="1500" b="1" i="0">
+                <a:solidFill>
+                  <a:srgbClr val="FFFFFF"/>
+                </a:solidFill>
+                <a:latin typeface="Calibri"/>
+              </a:rPr>
+              <a:t>Each layer is watched by the layer below it — so a host that is wrong, hung or unplugged cannot run the fan away.</a:t>
             </a:r>
           </a:p>
         </p:txBody>
@@ -5626,7 +5717,7 @@
           </a:fontRef>
         </p:style>
         <p:txBody>
-          <a:bodyPr rtlCol="0" anchor="ctr" wrap="square"/>
+          <a:bodyPr rtlCol="0" anchor="t" wrap="square"/>
           <a:lstStyle/>
           <a:p>
             <a:pPr algn="ctr"/>
@@ -5670,7 +5761,7 @@
           </a:fontRef>
         </p:style>
         <p:txBody>
-          <a:bodyPr rtlCol="0" anchor="ctr" wrap="square"/>
+          <a:bodyPr rtlCol="0" anchor="t" wrap="square"/>
           <a:lstStyle/>
           <a:p>
             <a:pPr algn="ctr"/>
@@ -5792,7 +5883,7 @@
           </a:fontRef>
         </p:style>
         <p:txBody>
-          <a:bodyPr rtlCol="0" anchor="ctr" wrap="square"/>
+          <a:bodyPr rtlCol="0" anchor="t" wrap="square"/>
           <a:lstStyle/>
           <a:p>
             <a:pPr algn="ctr"/>
@@ -5856,7 +5947,7 @@
         <p:spPr>
           <a:xfrm>
             <a:off x="502920" y="2103120"/>
-            <a:ext cx="6858000" cy="3566160"/>
+            <a:ext cx="6858000" cy="4023360"/>
           </a:xfrm>
           <a:prstGeom prst="rect">
             <a:avLst/>
@@ -5947,7 +6038,7 @@
         <p:spPr>
           <a:xfrm>
             <a:off x="7635240" y="2103120"/>
-            <a:ext cx="4069080" cy="3931920"/>
+            <a:ext cx="4069080" cy="4480560"/>
           </a:xfrm>
           <a:prstGeom prst="rect">
             <a:avLst/>
@@ -6079,7 +6170,7 @@
                 </a:solidFill>
                 <a:latin typeface="Calibri"/>
               </a:rPr>
-              <a:t>The top of P(I) is flat. The largest single sample is biased high, and the bias grows with the number of samples — so two blades measured with different point counts would be compared unfairly.</a:t>
+              <a:t>The top of P(I) is flat. The largest single sample is biased high, and the bias grows with sample count — so blades with different point counts would be compared unfairly.</a:t>
             </a:r>
           </a:p>
           <a:p>
@@ -6189,7 +6280,7 @@
           </a:fontRef>
         </p:style>
         <p:txBody>
-          <a:bodyPr rtlCol="0" anchor="ctr" wrap="square"/>
+          <a:bodyPr rtlCol="0" anchor="t" wrap="square"/>
           <a:lstStyle/>
           <a:p>
             <a:pPr algn="ctr"/>
@@ -6233,7 +6324,7 @@
           </a:fontRef>
         </p:style>
         <p:txBody>
-          <a:bodyPr rtlCol="0" anchor="ctr" wrap="square"/>
+          <a:bodyPr rtlCol="0" anchor="t" wrap="square"/>
           <a:lstStyle/>
           <a:p>
             <a:pPr algn="ctr"/>
@@ -6355,7 +6446,7 @@
           </a:fontRef>
         </p:style>
         <p:txBody>
-          <a:bodyPr rtlCol="0" anchor="ctr" wrap="square"/>
+          <a:bodyPr rtlCol="0" anchor="t" wrap="square"/>
           <a:lstStyle/>
           <a:p>
             <a:pPr algn="ctr"/>
@@ -7024,7 +7115,7 @@
         <p:spPr>
           <a:xfrm>
             <a:off x="502920" y="3995928"/>
-            <a:ext cx="5577840" cy="1481328"/>
+            <a:ext cx="5577840" cy="1572768"/>
           </a:xfrm>
           <a:prstGeom prst="rect">
             <a:avLst/>
@@ -7054,7 +7145,7 @@
           </a:fontRef>
         </p:style>
         <p:txBody>
-          <a:bodyPr rtlCol="0" anchor="ctr" wrap="square" lIns="182880" rIns="182880" tIns="137160"/>
+          <a:bodyPr rtlCol="0" anchor="t" wrap="square" lIns="182880" rIns="182880" tIns="137160"/>
           <a:lstStyle/>
           <a:p>
             <a:pPr algn="l">
@@ -7158,7 +7249,7 @@
         <p:spPr>
           <a:xfrm>
             <a:off x="6263640" y="1618488"/>
-            <a:ext cx="5394960" cy="3886200"/>
+            <a:ext cx="5394960" cy="3950208"/>
           </a:xfrm>
           <a:prstGeom prst="rect">
             <a:avLst/>
@@ -7188,7 +7279,7 @@
           </a:fontRef>
         </p:style>
         <p:txBody>
-          <a:bodyPr rtlCol="0" anchor="ctr" wrap="square" lIns="201168" rIns="201168" tIns="164592"/>
+          <a:bodyPr rtlCol="0" anchor="t" wrap="square" lIns="201168" rIns="201168" tIns="164592"/>
           <a:lstStyle/>
           <a:p>
             <a:pPr algn="l">
@@ -7253,55 +7344,71 @@
                 </a:solidFill>
                 <a:latin typeface="Calibri"/>
               </a:rPr>
-              <a:t>The v^3.77 exponent decomposes almost entirely into the generator, not the rotor:</a:t>
+              <a:t>The v^3.77 exponent decomposes into the generator, not the rotor:</a:t>
             </a:r>
           </a:p>
           <a:p>
             <a:pPr algn="l" lvl="1">
               <a:spcAft>
-                <a:spcPts val="600"/>
-              </a:spcAft>
-            </a:pPr>
-            <a:r>
-              <a:rPr sz="1200" b="0" i="0">
+                <a:spcPts val="500"/>
+              </a:spcAft>
+            </a:pPr>
+            <a:r>
+              <a:rPr sz="1150" b="0" i="0">
                 <a:solidFill>
                   <a:srgbClr val="002147"/>
                 </a:solidFill>
                 <a:latin typeface="Consolas"/>
               </a:rPr>
-              <a:t>V_oc ∝ v^1.52  and  R_int ∝ v^−0.64  (73.6 → 40.1 Ω)</a:t>
+              <a:t>V_oc ∝ v^1.52      R_int ∝ v^−0.64</a:t>
             </a:r>
           </a:p>
           <a:p>
             <a:pPr algn="l" lvl="1">
               <a:spcAft>
-                <a:spcPts val="600"/>
-              </a:spcAft>
-            </a:pPr>
-            <a:r>
-              <a:rPr sz="1200" b="0" i="0">
+                <a:spcPts val="500"/>
+              </a:spcAft>
+            </a:pPr>
+            <a:r>
+              <a:rPr sz="1150" b="0" i="0">
                 <a:solidFill>
                   <a:srgbClr val="002147"/>
                 </a:solidFill>
                 <a:latin typeface="Consolas"/>
               </a:rPr>
-              <a:t>every peak sits at the Thévenin match, P = V_oc²/4R_int</a:t>
+              <a:t>R_int falls 73.6 → 40.1 Ω across the range</a:t>
             </a:r>
           </a:p>
           <a:p>
             <a:pPr algn="l" lvl="1">
               <a:spcAft>
-                <a:spcPts val="600"/>
-              </a:spcAft>
-            </a:pPr>
-            <a:r>
-              <a:rPr sz="1200" b="0" i="0">
+                <a:spcPts val="500"/>
+              </a:spcAft>
+            </a:pPr>
+            <a:r>
+              <a:rPr sz="1150" b="0" i="0">
                 <a:solidFill>
                   <a:srgbClr val="002147"/>
                 </a:solidFill>
                 <a:latin typeface="Consolas"/>
               </a:rPr>
-              <a:t>n = 2a − b = 3.69, against 3.77 measured</a:t>
+              <a:t>peaks at the Thévenin match, P = V_oc²/4R_int</a:t>
+            </a:r>
+          </a:p>
+          <a:p>
+            <a:pPr algn="l" lvl="1">
+              <a:spcAft>
+                <a:spcPts val="500"/>
+              </a:spcAft>
+            </a:pPr>
+            <a:r>
+              <a:rPr sz="1150" b="0" i="0">
+                <a:solidFill>
+                  <a:srgbClr val="002147"/>
+                </a:solidFill>
+                <a:latin typeface="Consolas"/>
+              </a:rPr>
+              <a:t>n = 2a − b = 3.69   vs   3.77 measured</a:t>
             </a:r>
           </a:p>
           <a:p>
@@ -7361,6 +7468,63 @@
                 <a:latin typeface="Calibri"/>
               </a:rPr>
               <a:t>, roughly 100× below a working H-rotor, because peak power sits at ω/ω_runaway ≈ 0.70→0.94 — the far limb of Cp(λ) where Cp → 0 by construction.</a:t>
+            </a:r>
+          </a:p>
+        </p:txBody>
+      </p:sp>
+      <p:sp>
+        <p:nvSpPr>
+          <p:cNvPr id="11" name="Rectangle 10"/>
+          <p:cNvSpPr/>
+          <p:nvPr/>
+        </p:nvSpPr>
+        <p:spPr>
+          <a:xfrm>
+            <a:off x="502920" y="5742432"/>
+            <a:ext cx="11185855" cy="658368"/>
+          </a:xfrm>
+          <a:prstGeom prst="rect">
+            <a:avLst/>
+          </a:prstGeom>
+          <a:solidFill>
+            <a:srgbClr val="002147"/>
+          </a:solidFill>
+          <a:ln>
+            <a:noFill/>
+          </a:ln>
+          <a:effectLst/>
+        </p:spPr>
+        <p:style>
+          <a:lnRef idx="1">
+            <a:schemeClr val="accent1"/>
+          </a:lnRef>
+          <a:fillRef idx="3">
+            <a:schemeClr val="accent1"/>
+          </a:fillRef>
+          <a:effectRef idx="2">
+            <a:schemeClr val="accent1"/>
+          </a:effectRef>
+          <a:fontRef idx="minor">
+            <a:schemeClr val="lt1"/>
+          </a:fontRef>
+        </p:style>
+        <p:txBody>
+          <a:bodyPr rtlCol="0" anchor="ctr" wrap="square" lIns="256032"/>
+          <a:lstStyle/>
+          <a:p>
+            <a:pPr algn="l">
+              <a:spcAft>
+                <a:spcPts val="0"/>
+              </a:spcAft>
+            </a:pPr>
+            <a:r>
+              <a:rPr sz="1500" b="1" i="0">
+                <a:solidFill>
+                  <a:srgbClr val="FFFFFF"/>
+                </a:solidFill>
+                <a:latin typeface="Calibri"/>
+              </a:rPr>
+              <a:t>The measurement is sound. Its interpretation needs rotor speed — which is the next slide.</a:t>
             </a:r>
           </a:p>
         </p:txBody>
@@ -7420,7 +7584,7 @@
           </a:fontRef>
         </p:style>
         <p:txBody>
-          <a:bodyPr rtlCol="0" anchor="ctr" wrap="square"/>
+          <a:bodyPr rtlCol="0" anchor="t" wrap="square"/>
           <a:lstStyle/>
           <a:p>
             <a:pPr algn="ctr"/>
@@ -7464,7 +7628,7 @@
           </a:fontRef>
         </p:style>
         <p:txBody>
-          <a:bodyPr rtlCol="0" anchor="ctr" wrap="square"/>
+          <a:bodyPr rtlCol="0" anchor="t" wrap="square"/>
           <a:lstStyle/>
           <a:p>
             <a:pPr algn="ctr"/>
@@ -7586,7 +7750,7 @@
           </a:fontRef>
         </p:style>
         <p:txBody>
-          <a:bodyPr rtlCol="0" anchor="ctr" wrap="square"/>
+          <a:bodyPr rtlCol="0" anchor="t" wrap="square"/>
           <a:lstStyle/>
           <a:p>
             <a:pPr algn="ctr"/>
@@ -7677,7 +7841,7 @@
         <p:spPr>
           <a:xfrm>
             <a:off x="502920" y="2852928"/>
-            <a:ext cx="5486400" cy="2926080"/>
+            <a:ext cx="5486400" cy="2999232"/>
           </a:xfrm>
           <a:prstGeom prst="rect">
             <a:avLst/>
@@ -7707,7 +7871,7 @@
           </a:fontRef>
         </p:style>
         <p:txBody>
-          <a:bodyPr rtlCol="0" anchor="ctr" wrap="square" lIns="201168" rIns="201168" tIns="164592"/>
+          <a:bodyPr rtlCol="0" anchor="t" wrap="square" lIns="201168" rIns="201168" tIns="164592"/>
           <a:lstStyle/>
           <a:p>
             <a:pPr algn="l">
@@ -7747,7 +7911,7 @@
                 </a:solidFill>
                 <a:latin typeface="Calibri"/>
               </a:rPr>
-              <a:t>Without ω there is no λ and no Cp, so the rig cannot separate rotor aerodynamics from generator matching.</a:t>
+              <a:t>Without ω there is no λ and no Cp — the rig cannot separate rotor aerodynamics from generator matching.</a:t>
             </a:r>
           </a:p>
           <a:p>
@@ -7772,7 +7936,7 @@
                 </a:solidFill>
                 <a:latin typeface="Calibri"/>
               </a:rPr>
-              <a:t>A better blade can read as LESS power: anything that raises Cp_max while adding low-α drag lowers λ_runaway, lowers V_oc, and lowers measured P as the SQUARE of the speed change.</a:t>
+              <a:t>A better blade can read as LESS power: raising Cp_max while adding low-α drag lowers λ_runaway, lowers V_oc, and lowers measured P as the SQUARE.</a:t>
             </a:r>
           </a:p>
           <a:p>
@@ -7797,7 +7961,7 @@
                 </a:solidFill>
                 <a:latin typeface="Calibri"/>
               </a:rPr>
-              <a:t>Two rotors with Cp_max of 5% and 25% would rank purely by how freely they spin.</a:t>
+              <a:t>Two rotors at Cp_max 5% and 25% would rank purely by how freely they spin.</a:t>
             </a:r>
           </a:p>
         </p:txBody>
@@ -7811,7 +7975,7 @@
         <p:spPr>
           <a:xfrm>
             <a:off x="6172200" y="2852928"/>
-            <a:ext cx="5486400" cy="2926080"/>
+            <a:ext cx="5486400" cy="2999232"/>
           </a:xfrm>
           <a:prstGeom prst="rect">
             <a:avLst/>
@@ -7841,7 +8005,7 @@
           </a:fontRef>
         </p:style>
         <p:txBody>
-          <a:bodyPr rtlCol="0" anchor="ctr" wrap="square" lIns="201168" rIns="201168" tIns="164592"/>
+          <a:bodyPr rtlCol="0" anchor="t" wrap="square" lIns="201168" rIns="201168" tIns="164592"/>
           <a:lstStyle/>
           <a:p>
             <a:pPr algn="l">
@@ -7959,6 +8123,63 @@
                 <a:latin typeface="Calibri"/>
               </a:rPr>
               <a:t>), so fan speed and rotor speed share one time base. 0.000 V is a live zero meaning INVALID, not zero rpm.</a:t>
+            </a:r>
+          </a:p>
+        </p:txBody>
+      </p:sp>
+      <p:sp>
+        <p:nvSpPr>
+          <p:cNvPr id="10" name="Rectangle 9"/>
+          <p:cNvSpPr/>
+          <p:nvPr/>
+        </p:nvSpPr>
+        <p:spPr>
+          <a:xfrm>
+            <a:off x="502920" y="5742432"/>
+            <a:ext cx="11185855" cy="658368"/>
+          </a:xfrm>
+          <a:prstGeom prst="rect">
+            <a:avLst/>
+          </a:prstGeom>
+          <a:solidFill>
+            <a:srgbClr val="002147"/>
+          </a:solidFill>
+          <a:ln>
+            <a:noFill/>
+          </a:ln>
+          <a:effectLst/>
+        </p:spPr>
+        <p:style>
+          <a:lnRef idx="1">
+            <a:schemeClr val="accent1"/>
+          </a:lnRef>
+          <a:fillRef idx="3">
+            <a:schemeClr val="accent1"/>
+          </a:fillRef>
+          <a:effectRef idx="2">
+            <a:schemeClr val="accent1"/>
+          </a:effectRef>
+          <a:fontRef idx="minor">
+            <a:schemeClr val="lt1"/>
+          </a:fontRef>
+        </p:style>
+        <p:txBody>
+          <a:bodyPr rtlCol="0" anchor="ctr" wrap="square" lIns="256032"/>
+          <a:lstStyle/>
+          <a:p>
+            <a:pPr algn="l">
+              <a:spcAft>
+                <a:spcPts val="0"/>
+              </a:spcAft>
+            </a:pPr>
+            <a:r>
+              <a:rPr sz="1500" b="1" i="0">
+                <a:solidFill>
+                  <a:srgbClr val="FFFFFF"/>
+                </a:solidFill>
+                <a:latin typeface="Calibri"/>
+              </a:rPr>
+              <a:t>The ask is two numbers: which DAQ channel, and how many pulses per revolution.</a:t>
             </a:r>
           </a:p>
         </p:txBody>
@@ -8018,7 +8239,7 @@
           </a:fontRef>
         </p:style>
         <p:txBody>
-          <a:bodyPr rtlCol="0" anchor="ctr" wrap="square"/>
+          <a:bodyPr rtlCol="0" anchor="t" wrap="square"/>
           <a:lstStyle/>
           <a:p>
             <a:pPr algn="ctr"/>
@@ -8062,7 +8283,7 @@
           </a:fontRef>
         </p:style>
         <p:txBody>
-          <a:bodyPr rtlCol="0" anchor="ctr" wrap="square"/>
+          <a:bodyPr rtlCol="0" anchor="t" wrap="square"/>
           <a:lstStyle/>
           <a:p>
             <a:pPr algn="ctr"/>
@@ -8184,7 +8405,7 @@
           </a:fontRef>
         </p:style>
         <p:txBody>
-          <a:bodyPr rtlCol="0" anchor="ctr" wrap="square"/>
+          <a:bodyPr rtlCol="0" anchor="t" wrap="square"/>
           <a:lstStyle/>
           <a:p>
             <a:pPr algn="ctr"/>
@@ -8239,7 +8460,7 @@
         <p:spPr>
           <a:xfrm>
             <a:off x="502920" y="2103120"/>
-            <a:ext cx="5486400" cy="1170432"/>
+            <a:ext cx="5486400" cy="1426464"/>
           </a:xfrm>
           <a:prstGeom prst="rect">
             <a:avLst/>
@@ -8269,7 +8490,7 @@
           </a:fontRef>
         </p:style>
         <p:txBody>
-          <a:bodyPr rtlCol="0" anchor="ctr" wrap="square" lIns="182880" rIns="182880" tIns="118872"/>
+          <a:bodyPr rtlCol="0" anchor="t" wrap="square" lIns="182880" rIns="182880" tIns="118872"/>
           <a:lstStyle/>
           <a:p>
             <a:pPr algn="l">
@@ -8314,7 +8535,7 @@
         <p:spPr>
           <a:xfrm>
             <a:off x="6172200" y="2103120"/>
-            <a:ext cx="5486400" cy="1170432"/>
+            <a:ext cx="5486400" cy="1426464"/>
           </a:xfrm>
           <a:prstGeom prst="rect">
             <a:avLst/>
@@ -8344,7 +8565,7 @@
           </a:fontRef>
         </p:style>
         <p:txBody>
-          <a:bodyPr rtlCol="0" anchor="ctr" wrap="square" lIns="182880" rIns="182880" tIns="118872"/>
+          <a:bodyPr rtlCol="0" anchor="t" wrap="square" lIns="182880" rIns="182880" tIns="118872"/>
           <a:lstStyle/>
           <a:p>
             <a:pPr algn="l">
@@ -8375,7 +8596,7 @@
                 </a:solidFill>
                 <a:latin typeface="Calibri"/>
               </a:rPr>
-              <a:t>1.79 mm constant wall, t/c 4%, 42% camber, 183° turning, square-cut edges. Separation is pinned by geometry, so any XFOIL or polar cross-check is answering a question about a different part.</a:t>
+              <a:t>1.79 mm wall, t/c 4%, 42% camber, square-cut edges. Separation is pinned by geometry, so XFOIL and polar cross-checks answer a different question.</a:t>
             </a:r>
           </a:p>
         </p:txBody>
@@ -8388,8 +8609,8 @@
         </p:nvSpPr>
         <p:spPr>
           <a:xfrm>
-            <a:off x="502920" y="3401568"/>
-            <a:ext cx="5486400" cy="1170432"/>
+            <a:off x="502920" y="3675888"/>
+            <a:ext cx="5486400" cy="1426464"/>
           </a:xfrm>
           <a:prstGeom prst="rect">
             <a:avLst/>
@@ -8419,7 +8640,7 @@
           </a:fontRef>
         </p:style>
         <p:txBody>
-          <a:bodyPr rtlCol="0" anchor="ctr" wrap="square" lIns="182880" rIns="182880" tIns="118872"/>
+          <a:bodyPr rtlCol="0" anchor="t" wrap="square" lIns="182880" rIns="182880" tIns="118872"/>
           <a:lstStyle/>
           <a:p>
             <a:pPr algn="l">
@@ -8463,8 +8684,8 @@
         </p:nvSpPr>
         <p:spPr>
           <a:xfrm>
-            <a:off x="6172200" y="3401568"/>
-            <a:ext cx="5486400" cy="1170432"/>
+            <a:off x="6172200" y="3675888"/>
+            <a:ext cx="5486400" cy="1426464"/>
           </a:xfrm>
           <a:prstGeom prst="rect">
             <a:avLst/>
@@ -8494,7 +8715,7 @@
           </a:fontRef>
         </p:style>
         <p:txBody>
-          <a:bodyPr rtlCol="0" anchor="ctr" wrap="square" lIns="182880" rIns="182880" tIns="118872"/>
+          <a:bodyPr rtlCol="0" anchor="t" wrap="square" lIns="182880" rIns="182880" tIns="118872"/>
           <a:lstStyle/>
           <a:p>
             <a:pPr algn="l">
@@ -8538,8 +8759,8 @@
         </p:nvSpPr>
         <p:spPr>
           <a:xfrm>
-            <a:off x="502920" y="4700016"/>
-            <a:ext cx="5486400" cy="1170432"/>
+            <a:off x="502920" y="5248656"/>
+            <a:ext cx="5486400" cy="1426464"/>
           </a:xfrm>
           <a:prstGeom prst="rect">
             <a:avLst/>
@@ -8569,7 +8790,7 @@
           </a:fontRef>
         </p:style>
         <p:txBody>
-          <a:bodyPr rtlCol="0" anchor="ctr" wrap="square" lIns="182880" rIns="182880" tIns="118872"/>
+          <a:bodyPr rtlCol="0" anchor="t" wrap="square" lIns="182880" rIns="182880" tIns="118872"/>
           <a:lstStyle/>
           <a:p>
             <a:pPr algn="l">
@@ -8613,8 +8834,8 @@
         </p:nvSpPr>
         <p:spPr>
           <a:xfrm>
-            <a:off x="6172200" y="4700016"/>
-            <a:ext cx="5486400" cy="1170432"/>
+            <a:off x="6172200" y="5248656"/>
+            <a:ext cx="5486400" cy="1426464"/>
           </a:xfrm>
           <a:prstGeom prst="rect">
             <a:avLst/>
@@ -8644,7 +8865,7 @@
           </a:fontRef>
         </p:style>
         <p:txBody>
-          <a:bodyPr rtlCol="0" anchor="ctr" wrap="square" lIns="182880" rIns="182880" tIns="118872"/>
+          <a:bodyPr rtlCol="0" anchor="t" wrap="square" lIns="182880" rIns="182880" tIns="118872"/>
           <a:lstStyle/>
           <a:p>
             <a:pPr algn="l">

</xml_diff>